<commit_message>
Add course/week framing and a 4-topic nav strip to each deck's opener
Each standalone file's first slide now carries "BlockchainCourse ·
Week 01 · Topic X of 04" context plus a small nav strip showing all
four topics with the current one highlighted, so a deck opened on
its own no longer starts cold with no sense of the larger course.
</commit_message>
<xml_diff>
--- a/curriculum/week-01/week1-topic-01-hashing.pptx
+++ b/curriculum/week-01/week1-topic-01-hashing.pptx
@@ -3270,8 +3270,8 @@
         </p:nvSpPr>
         <p:spPr>
           <a:xfrm>
-            <a:off x="822960" y="1188720"/>
-            <a:ext cx="5486400" cy="1188720"/>
+            <a:off x="822960" y="502920"/>
+            <a:ext cx="9144000" cy="365760"/>
           </a:xfrm>
           <a:prstGeom prst="rect">
             <a:avLst/>
@@ -3290,13 +3290,13 @@
               </a:lnSpc>
             </a:pPr>
             <a:r>
-              <a:rPr sz="10000" b="1" i="0">
-                <a:solidFill>
-                  <a:srgbClr val="FFFFFF"/>
-                </a:solidFill>
-                <a:latin typeface="Century Gothic"/>
-              </a:rPr>
-              <a:t>01</a:t>
+              <a:rPr sz="1300" b="1" i="0">
+                <a:solidFill>
+                  <a:srgbClr val="FFC53D"/>
+                </a:solidFill>
+                <a:latin typeface="Calibri"/>
+              </a:rPr>
+              <a:t>BlockchainCourse · Curriculum · Week 01 · Topic 01 of 04</a:t>
             </a:r>
           </a:p>
         </p:txBody>
@@ -3309,8 +3309,8 @@
         </p:nvSpPr>
         <p:spPr>
           <a:xfrm>
-            <a:off x="822960" y="2423160"/>
-            <a:ext cx="8961120" cy="1554480"/>
+            <a:off x="822960" y="1188720"/>
+            <a:ext cx="5486400" cy="1188720"/>
           </a:xfrm>
           <a:prstGeom prst="rect">
             <a:avLst/>
@@ -3325,17 +3325,17 @@
           <a:p>
             <a:pPr algn="l">
               <a:lnSpc>
-                <a:spcPct val="105000"/>
-              </a:lnSpc>
-            </a:pPr>
-            <a:r>
-              <a:rPr sz="4600" b="1" i="0">
+                <a:spcPct val="115000"/>
+              </a:lnSpc>
+            </a:pPr>
+            <a:r>
+              <a:rPr sz="10000" b="1" i="0">
                 <a:solidFill>
                   <a:srgbClr val="FFFFFF"/>
                 </a:solidFill>
                 <a:latin typeface="Century Gothic"/>
               </a:rPr>
-              <a:t>Hashing</a:t>
+              <a:t>01</a:t>
             </a:r>
           </a:p>
         </p:txBody>
@@ -3348,8 +3348,8 @@
         </p:nvSpPr>
         <p:spPr>
           <a:xfrm>
-            <a:off x="822960" y="4160520"/>
-            <a:ext cx="6858000" cy="1097280"/>
+            <a:off x="822960" y="2423160"/>
+            <a:ext cx="8961120" cy="1554480"/>
           </a:xfrm>
           <a:prstGeom prst="rect">
             <a:avLst/>
@@ -3364,17 +3364,17 @@
           <a:p>
             <a:pPr algn="l">
               <a:lnSpc>
-                <a:spcPct val="125000"/>
-              </a:lnSpc>
-            </a:pPr>
-            <a:r>
-              <a:rPr sz="1900" b="0" i="0">
+                <a:spcPct val="105000"/>
+              </a:lnSpc>
+            </a:pPr>
+            <a:r>
+              <a:rPr sz="4600" b="1" i="0">
                 <a:solidFill>
                   <a:srgbClr val="FFFFFF"/>
                 </a:solidFill>
-                <a:latin typeface="Calibri"/>
-              </a:rPr>
-              <a:t>A tamper-evident fingerprint for data — change one letter, get an unrecognizable result.</a:t>
+                <a:latin typeface="Century Gothic"/>
+              </a:rPr>
+              <a:t>Hashing</a:t>
             </a:r>
           </a:p>
         </p:txBody>
@@ -3387,8 +3387,8 @@
         </p:nvSpPr>
         <p:spPr>
           <a:xfrm>
-            <a:off x="822960" y="6446520"/>
-            <a:ext cx="8229600" cy="320040"/>
+            <a:off x="822960" y="4160520"/>
+            <a:ext cx="6858000" cy="1097280"/>
           </a:xfrm>
           <a:prstGeom prst="rect">
             <a:avLst/>
@@ -3403,6 +3403,277 @@
           <a:p>
             <a:pPr algn="l">
               <a:lnSpc>
+                <a:spcPct val="125000"/>
+              </a:lnSpc>
+            </a:pPr>
+            <a:r>
+              <a:rPr sz="1900" b="0" i="0">
+                <a:solidFill>
+                  <a:srgbClr val="FFFFFF"/>
+                </a:solidFill>
+                <a:latin typeface="Calibri"/>
+              </a:rPr>
+              <a:t>A tamper-evident fingerprint for data — change one letter, get an unrecognizable result.</a:t>
+            </a:r>
+          </a:p>
+        </p:txBody>
+      </p:sp>
+      <p:sp>
+        <p:nvSpPr>
+          <p:cNvPr id="10" name="Rounded Rectangle 9"/>
+          <p:cNvSpPr/>
+          <p:nvPr/>
+        </p:nvSpPr>
+        <p:spPr>
+          <a:xfrm>
+            <a:off x="822960" y="5669280"/>
+            <a:ext cx="1100937" cy="402336"/>
+          </a:xfrm>
+          <a:prstGeom prst="roundRect">
+            <a:avLst>
+              <a:gd name="adj" fmla="val 50000"/>
+            </a:avLst>
+          </a:prstGeom>
+          <a:solidFill>
+            <a:srgbClr val="C1432B"/>
+          </a:solidFill>
+          <a:ln>
+            <a:noFill/>
+          </a:ln>
+          <a:effectLst/>
+        </p:spPr>
+        <p:style>
+          <a:lnRef idx="1">
+            <a:schemeClr val="accent1"/>
+          </a:lnRef>
+          <a:fillRef idx="3">
+            <a:schemeClr val="accent1"/>
+          </a:fillRef>
+          <a:effectRef idx="2">
+            <a:schemeClr val="accent1"/>
+          </a:effectRef>
+          <a:fontRef idx="minor">
+            <a:schemeClr val="lt1"/>
+          </a:fontRef>
+        </p:style>
+        <p:txBody>
+          <a:bodyPr rtlCol="0" anchor="ctr" lIns="109728" rIns="109728" tIns="18288" bIns="18288" wrap="none"/>
+          <a:lstStyle/>
+          <a:p>
+            <a:pPr algn="ctr"/>
+            <a:r>
+              <a:rPr sz="1100" b="1">
+                <a:solidFill>
+                  <a:srgbClr val="FFFFFF"/>
+                </a:solidFill>
+                <a:latin typeface="Calibri"/>
+              </a:rPr>
+              <a:t>01 · Hashing</a:t>
+            </a:r>
+          </a:p>
+        </p:txBody>
+      </p:sp>
+      <p:sp>
+        <p:nvSpPr>
+          <p:cNvPr id="11" name="Rounded Rectangle 10"/>
+          <p:cNvSpPr/>
+          <p:nvPr/>
+        </p:nvSpPr>
+        <p:spPr>
+          <a:xfrm>
+            <a:off x="2070201" y="5669280"/>
+            <a:ext cx="2022652" cy="402336"/>
+          </a:xfrm>
+          <a:prstGeom prst="roundRect">
+            <a:avLst>
+              <a:gd name="adj" fmla="val 50000"/>
+            </a:avLst>
+          </a:prstGeom>
+          <a:solidFill>
+            <a:srgbClr val="FFFFFF">
+              <a:alpha val="14000"/>
+            </a:srgbClr>
+          </a:solidFill>
+          <a:ln w="9525">
+            <a:solidFill>
+              <a:srgbClr val="FFFFFF"/>
+            </a:solidFill>
+          </a:ln>
+          <a:effectLst/>
+        </p:spPr>
+        <p:style>
+          <a:lnRef idx="1">
+            <a:schemeClr val="accent1"/>
+          </a:lnRef>
+          <a:fillRef idx="3">
+            <a:schemeClr val="accent1"/>
+          </a:fillRef>
+          <a:effectRef idx="2">
+            <a:schemeClr val="accent1"/>
+          </a:effectRef>
+          <a:fontRef idx="minor">
+            <a:schemeClr val="lt1"/>
+          </a:fontRef>
+        </p:style>
+        <p:txBody>
+          <a:bodyPr rtlCol="0" anchor="ctr" lIns="109728" rIns="109728" tIns="18288" bIns="18288" wrap="none"/>
+          <a:lstStyle/>
+          <a:p>
+            <a:pPr algn="ctr"/>
+            <a:r>
+              <a:rPr sz="1100" b="0">
+                <a:solidFill>
+                  <a:srgbClr val="DDD9E8"/>
+                </a:solidFill>
+                <a:latin typeface="Calibri"/>
+              </a:rPr>
+              <a:t>02 · Public / Private Keys</a:t>
+            </a:r>
+          </a:p>
+        </p:txBody>
+      </p:sp>
+      <p:sp>
+        <p:nvSpPr>
+          <p:cNvPr id="12" name="Rounded Rectangle 11"/>
+          <p:cNvSpPr/>
+          <p:nvPr/>
+        </p:nvSpPr>
+        <p:spPr>
+          <a:xfrm>
+            <a:off x="4239157" y="5669280"/>
+            <a:ext cx="1627632" cy="402336"/>
+          </a:xfrm>
+          <a:prstGeom prst="roundRect">
+            <a:avLst>
+              <a:gd name="adj" fmla="val 50000"/>
+            </a:avLst>
+          </a:prstGeom>
+          <a:solidFill>
+            <a:srgbClr val="FFFFFF">
+              <a:alpha val="14000"/>
+            </a:srgbClr>
+          </a:solidFill>
+          <a:ln w="9525">
+            <a:solidFill>
+              <a:srgbClr val="FFFFFF"/>
+            </a:solidFill>
+          </a:ln>
+          <a:effectLst/>
+        </p:spPr>
+        <p:style>
+          <a:lnRef idx="1">
+            <a:schemeClr val="accent1"/>
+          </a:lnRef>
+          <a:fillRef idx="3">
+            <a:schemeClr val="accent1"/>
+          </a:fillRef>
+          <a:effectRef idx="2">
+            <a:schemeClr val="accent1"/>
+          </a:effectRef>
+          <a:fontRef idx="minor">
+            <a:schemeClr val="lt1"/>
+          </a:fontRef>
+        </p:style>
+        <p:txBody>
+          <a:bodyPr rtlCol="0" anchor="ctr" lIns="109728" rIns="109728" tIns="18288" bIns="18288" wrap="none"/>
+          <a:lstStyle/>
+          <a:p>
+            <a:pPr algn="ctr"/>
+            <a:r>
+              <a:rPr sz="1100" b="0">
+                <a:solidFill>
+                  <a:srgbClr val="DDD9E8"/>
+                </a:solidFill>
+                <a:latin typeface="Calibri"/>
+              </a:rPr>
+              <a:t>03 · Blocks &amp; Chains</a:t>
+            </a:r>
+          </a:p>
+        </p:txBody>
+      </p:sp>
+      <p:sp>
+        <p:nvSpPr>
+          <p:cNvPr id="13" name="Rounded Rectangle 12"/>
+          <p:cNvSpPr/>
+          <p:nvPr/>
+        </p:nvSpPr>
+        <p:spPr>
+          <a:xfrm>
+            <a:off x="6013093" y="5669280"/>
+            <a:ext cx="1232611" cy="402336"/>
+          </a:xfrm>
+          <a:prstGeom prst="roundRect">
+            <a:avLst>
+              <a:gd name="adj" fmla="val 50000"/>
+            </a:avLst>
+          </a:prstGeom>
+          <a:solidFill>
+            <a:srgbClr val="FFFFFF">
+              <a:alpha val="14000"/>
+            </a:srgbClr>
+          </a:solidFill>
+          <a:ln w="9525">
+            <a:solidFill>
+              <a:srgbClr val="FFFFFF"/>
+            </a:solidFill>
+          </a:ln>
+          <a:effectLst/>
+        </p:spPr>
+        <p:style>
+          <a:lnRef idx="1">
+            <a:schemeClr val="accent1"/>
+          </a:lnRef>
+          <a:fillRef idx="3">
+            <a:schemeClr val="accent1"/>
+          </a:fillRef>
+          <a:effectRef idx="2">
+            <a:schemeClr val="accent1"/>
+          </a:effectRef>
+          <a:fontRef idx="minor">
+            <a:schemeClr val="lt1"/>
+          </a:fontRef>
+        </p:style>
+        <p:txBody>
+          <a:bodyPr rtlCol="0" anchor="ctr" lIns="109728" rIns="109728" tIns="18288" bIns="18288" wrap="none"/>
+          <a:lstStyle/>
+          <a:p>
+            <a:pPr algn="ctr"/>
+            <a:r>
+              <a:rPr sz="1100" b="0">
+                <a:solidFill>
+                  <a:srgbClr val="DDD9E8"/>
+                </a:solidFill>
+                <a:latin typeface="Calibri"/>
+              </a:rPr>
+              <a:t>04 · Consensus</a:t>
+            </a:r>
+          </a:p>
+        </p:txBody>
+      </p:sp>
+      <p:sp>
+        <p:nvSpPr>
+          <p:cNvPr id="14" name="TextBox 13"/>
+          <p:cNvSpPr txBox="1"/>
+          <p:nvPr/>
+        </p:nvSpPr>
+        <p:spPr>
+          <a:xfrm>
+            <a:off x="822960" y="6446520"/>
+            <a:ext cx="8229600" cy="320040"/>
+          </a:xfrm>
+          <a:prstGeom prst="rect">
+            <a:avLst/>
+          </a:prstGeom>
+          <a:noFill/>
+        </p:spPr>
+        <p:txBody>
+          <a:bodyPr wrap="square" anchor="t" lIns="0" rIns="0" tIns="0" bIns="0">
+            <a:spAutoFit/>
+          </a:bodyPr>
+          <a:lstStyle/>
+          <a:p>
+            <a:pPr algn="l">
+              <a:lnSpc>
                 <a:spcPct val="115000"/>
               </a:lnSpc>
             </a:pPr>
@@ -3420,7 +3691,7 @@
       </p:sp>
       <p:sp>
         <p:nvSpPr>
-          <p:cNvPr id="10" name="TextBox 9"/>
+          <p:cNvPr id="15" name="TextBox 14"/>
           <p:cNvSpPr txBox="1"/>
           <p:nvPr/>
         </p:nvSpPr>

</xml_diff>